<commit_message>
Publicar v1.1.0 post-TFG como proyecto personal.
Reencuadra documentación y versión, compacta el arranque de modos en la UI y separa las utilidades de distribución del pipeline académico.

Co-authored-by: Cursor <cursoragent@cursor.com>
</commit_message>
<xml_diff>
--- a/Docs/Entrega/Presentacion_TFG.pptx
+++ b/Docs/Entrega/Presentacion_TFG.pptx
@@ -943,7 +943,7 @@
           <a:lstStyle/>
           <a:p>
             <a:r>
-              <a:t>Ejemplo materias exigentes: Càlcul DV, Probabilitat, Anàlisi Complexa.</a:t>
+              <a:t>Carrusel de presets con prioridad histórica. Ejemplo materias exigentes: Càlcul DV, Probabilitat, Anàlisi Complexa.</a:t>
             </a:r>
           </a:p>
         </p:txBody>
@@ -1153,7 +1153,7 @@
           <a:lstStyle/>
           <a:p>
             <a:r>
-              <a:t>Valida el motor de corrección; convergencia en memoria §5.7.</a:t>
+              <a:t>Valida el motor de corrección; detalle en memoria §5.7.</a:t>
             </a:r>
           </a:p>
         </p:txBody>
@@ -6515,7 +6515,7 @@
         <p:spPr>
           <a:xfrm>
             <a:off x="384048" y="987552"/>
-            <a:ext cx="8375904" cy="3721608"/>
+            <a:ext cx="3073115" cy="3721608"/>
           </a:xfrm>
           <a:prstGeom prst="rect">
             <a:avLst/>
@@ -6619,6 +6619,30 @@
           </a:p>
         </p:txBody>
       </p:sp>
+      <p:pic>
+        <p:nvPicPr>
+          <p:cNvPr id="6" name="Picture 5" descr="tfg_historia_carrusel.png"/>
+          <p:cNvPicPr>
+            <a:picLocks noChangeAspect="1"/>
+          </p:cNvPicPr>
+          <p:nvPr/>
+        </p:nvPicPr>
+        <p:blipFill>
+          <a:blip r:embed="rId2"/>
+          <a:stretch>
+            <a:fillRect/>
+          </a:stretch>
+        </p:blipFill>
+        <p:spPr>
+          <a:xfrm>
+            <a:off x="3566891" y="987552"/>
+            <a:ext cx="4962144" cy="3721608"/>
+          </a:xfrm>
+          <a:prstGeom prst="rect">
+            <a:avLst/>
+          </a:prstGeom>
+        </p:spPr>
+      </p:pic>
     </p:spTree>
   </p:cSld>
   <p:clrMapOvr>
@@ -6759,7 +6783,7 @@
         <p:spPr>
           <a:xfrm>
             <a:off x="384048" y="987552"/>
-            <a:ext cx="3073115" cy="3721608"/>
+            <a:ext cx="8375904" cy="960120"/>
           </a:xfrm>
           <a:prstGeom prst="rect">
             <a:avLst/>
@@ -6825,29 +6849,11 @@
               <a:t>Inventario compartido entre modos arcade.</a:t>
             </a:r>
           </a:p>
-          <a:p>
-            <a:pPr>
-              <a:lnSpc>
-                <a:spcPct val="105000"/>
-              </a:lnSpc>
-              <a:spcAft>
-                <a:spcPts val="300"/>
-              </a:spcAft>
-            </a:pPr>
-            <a:r>
-              <a:rPr sz="1300">
-                <a:solidFill>
-                  <a:srgbClr val="2A2A2A"/>
-                </a:solidFill>
-              </a:rPr>
-              <a:t>Estadísticas locales y récords por modo.</a:t>
-            </a:r>
-          </a:p>
         </p:txBody>
       </p:sp>
       <p:pic>
         <p:nvPicPr>
-          <p:cNvPr id="6" name="Picture 5" descr="tfg_escape_tienda.png"/>
+          <p:cNvPr id="6" name="Picture 5" descr="tfg_resistencia_partida.png"/>
           <p:cNvPicPr>
             <a:picLocks noChangeAspect="1"/>
           </p:cNvPicPr>
@@ -6861,14 +6867,108 @@
         </p:blipFill>
         <p:spPr>
           <a:xfrm>
-            <a:off x="3566891" y="987552"/>
-            <a:ext cx="4962144" cy="3721608"/>
+            <a:off x="384048" y="1984248"/>
+            <a:ext cx="3218688" cy="2414016"/>
           </a:xfrm>
           <a:prstGeom prst="rect">
             <a:avLst/>
           </a:prstGeom>
         </p:spPr>
       </p:pic>
+      <p:sp>
+        <p:nvSpPr>
+          <p:cNvPr id="7" name="TextBox 6"/>
+          <p:cNvSpPr txBox="1"/>
+          <p:nvPr/>
+        </p:nvSpPr>
+        <p:spPr>
+          <a:xfrm>
+            <a:off x="384048" y="4443984"/>
+            <a:ext cx="4123944" cy="256032"/>
+          </a:xfrm>
+          <a:prstGeom prst="rect">
+            <a:avLst/>
+          </a:prstGeom>
+          <a:noFill/>
+        </p:spPr>
+        <p:txBody>
+          <a:bodyPr wrap="none">
+            <a:spAutoFit/>
+          </a:bodyPr>
+          <a:lstStyle/>
+          <a:p>
+            <a:pPr algn="ctr">
+              <a:defRPr sz="1000">
+                <a:solidFill>
+                  <a:srgbClr val="888888"/>
+                </a:solidFill>
+              </a:defRPr>
+            </a:pPr>
+            <a:r>
+              <a:t>Modo resistencia — partida en curso</a:t>
+            </a:r>
+          </a:p>
+        </p:txBody>
+      </p:sp>
+      <p:pic>
+        <p:nvPicPr>
+          <p:cNvPr id="8" name="Picture 7" descr="tfg_escape_tienda.png"/>
+          <p:cNvPicPr>
+            <a:picLocks noChangeAspect="1"/>
+          </p:cNvPicPr>
+          <p:nvPr/>
+        </p:nvPicPr>
+        <p:blipFill>
+          <a:blip r:embed="rId3"/>
+          <a:stretch>
+            <a:fillRect/>
+          </a:stretch>
+        </p:blipFill>
+        <p:spPr>
+          <a:xfrm>
+            <a:off x="4636007" y="1984248"/>
+            <a:ext cx="3218688" cy="2414016"/>
+          </a:xfrm>
+          <a:prstGeom prst="rect">
+            <a:avLst/>
+          </a:prstGeom>
+        </p:spPr>
+      </p:pic>
+      <p:sp>
+        <p:nvSpPr>
+          <p:cNvPr id="9" name="TextBox 8"/>
+          <p:cNvSpPr txBox="1"/>
+          <p:nvPr/>
+        </p:nvSpPr>
+        <p:spPr>
+          <a:xfrm>
+            <a:off x="4636007" y="4443984"/>
+            <a:ext cx="4123944" cy="256032"/>
+          </a:xfrm>
+          <a:prstGeom prst="rect">
+            <a:avLst/>
+          </a:prstGeom>
+          <a:noFill/>
+        </p:spPr>
+        <p:txBody>
+          <a:bodyPr wrap="none">
+            <a:spAutoFit/>
+          </a:bodyPr>
+          <a:lstStyle/>
+          <a:p>
+            <a:pPr algn="ctr">
+              <a:defRPr sz="1000">
+                <a:solidFill>
+                  <a:srgbClr val="888888"/>
+                </a:solidFill>
+              </a:defRPr>
+            </a:pPr>
+            <a:r>
+              <a:t>Escape room — tienda entre salas</a:t>
+            </a:r>
+          </a:p>
+        </p:txBody>
+      </p:sp>
     </p:spTree>
   </p:cSld>
   <p:clrMapOvr>
@@ -7559,7 +7659,7 @@
         <p:spPr>
           <a:xfrm>
             <a:off x="384048" y="987552"/>
-            <a:ext cx="3073115" cy="3721608"/>
+            <a:ext cx="8375904" cy="960120"/>
           </a:xfrm>
           <a:prstGeom prst="rect">
             <a:avLst/>
@@ -7661,14 +7761,108 @@
         </p:blipFill>
         <p:spPr>
           <a:xfrm>
-            <a:off x="3566891" y="1815058"/>
-            <a:ext cx="5193060" cy="2066594"/>
+            <a:off x="384048" y="1984248"/>
+            <a:ext cx="4123944" cy="1641136"/>
           </a:xfrm>
           <a:prstGeom prst="rect">
             <a:avLst/>
           </a:prstGeom>
         </p:spPr>
       </p:pic>
+      <p:sp>
+        <p:nvSpPr>
+          <p:cNvPr id="7" name="TextBox 6"/>
+          <p:cNvSpPr txBox="1"/>
+          <p:nvPr/>
+        </p:nvSpPr>
+        <p:spPr>
+          <a:xfrm>
+            <a:off x="384048" y="3671104"/>
+            <a:ext cx="4123944" cy="256032"/>
+          </a:xfrm>
+          <a:prstGeom prst="rect">
+            <a:avLst/>
+          </a:prstGeom>
+          <a:noFill/>
+        </p:spPr>
+        <p:txBody>
+          <a:bodyPr wrap="none">
+            <a:spAutoFit/>
+          </a:bodyPr>
+          <a:lstStyle/>
+          <a:p>
+            <a:pPr algn="ctr">
+              <a:defRPr sz="1000">
+                <a:solidFill>
+                  <a:srgbClr val="888888"/>
+                </a:solidFill>
+              </a:defRPr>
+            </a:pPr>
+            <a:r>
+              <a:t>Histograma de notas</a:t>
+            </a:r>
+          </a:p>
+        </p:txBody>
+      </p:sp>
+      <p:pic>
+        <p:nvPicPr>
+          <p:cNvPr id="8" name="Picture 7" descr="monte_carlo_convergencia.png"/>
+          <p:cNvPicPr>
+            <a:picLocks noChangeAspect="1"/>
+          </p:cNvPicPr>
+          <p:nvPr/>
+        </p:nvPicPr>
+        <p:blipFill>
+          <a:blip r:embed="rId3"/>
+          <a:stretch>
+            <a:fillRect/>
+          </a:stretch>
+        </p:blipFill>
+        <p:spPr>
+          <a:xfrm>
+            <a:off x="4636007" y="1984248"/>
+            <a:ext cx="4123944" cy="2212181"/>
+          </a:xfrm>
+          <a:prstGeom prst="rect">
+            <a:avLst/>
+          </a:prstGeom>
+        </p:spPr>
+      </p:pic>
+      <p:sp>
+        <p:nvSpPr>
+          <p:cNvPr id="9" name="TextBox 8"/>
+          <p:cNvSpPr txBox="1"/>
+          <p:nvPr/>
+        </p:nvSpPr>
+        <p:spPr>
+          <a:xfrm>
+            <a:off x="4636007" y="4242149"/>
+            <a:ext cx="4123944" cy="256032"/>
+          </a:xfrm>
+          <a:prstGeom prst="rect">
+            <a:avLst/>
+          </a:prstGeom>
+          <a:noFill/>
+        </p:spPr>
+        <p:txBody>
+          <a:bodyPr wrap="none">
+            <a:spAutoFit/>
+          </a:bodyPr>
+          <a:lstStyle/>
+          <a:p>
+            <a:pPr algn="ctr">
+              <a:defRPr sz="1000">
+                <a:solidFill>
+                  <a:srgbClr val="888888"/>
+                </a:solidFill>
+              </a:defRPr>
+            </a:pPr>
+            <a:r>
+              <a:t>Convergencia de la media</a:t>
+            </a:r>
+          </a:p>
+        </p:txBody>
+      </p:sp>
     </p:spTree>
   </p:cSld>
   <p:clrMapOvr>
@@ -7844,7 +8038,7 @@
         <p:spPr>
           <a:xfrm>
             <a:off x="384048" y="1335024"/>
-            <a:ext cx="4073652" cy="886968"/>
+            <a:ext cx="4073652" cy="1066739"/>
           </a:xfrm>
           <a:prstGeom prst="rect">
             <a:avLst/>
@@ -7956,7 +8150,7 @@
         <p:spPr>
           <a:xfrm>
             <a:off x="4686300" y="1335024"/>
-            <a:ext cx="4073652" cy="886968"/>
+            <a:ext cx="4073652" cy="1066739"/>
           </a:xfrm>
           <a:prstGeom prst="rect">
             <a:avLst/>
@@ -8040,8 +8234,32 @@
         </p:blipFill>
         <p:spPr>
           <a:xfrm>
-            <a:off x="384048" y="2276856"/>
-            <a:ext cx="3911356" cy="2432304"/>
+            <a:off x="384048" y="2456627"/>
+            <a:ext cx="3622269" cy="2252532"/>
+          </a:xfrm>
+          <a:prstGeom prst="rect">
+            <a:avLst/>
+          </a:prstGeom>
+        </p:spPr>
+      </p:pic>
+      <p:pic>
+        <p:nvPicPr>
+          <p:cNvPr id="10" name="Picture 9" descr="pity_distribucion_primer_descanso.png"/>
+          <p:cNvPicPr>
+            <a:picLocks noChangeAspect="1"/>
+          </p:cNvPicPr>
+          <p:nvPr/>
+        </p:nvPicPr>
+        <p:blipFill>
+          <a:blip r:embed="rId3"/>
+          <a:stretch>
+            <a:fillRect/>
+          </a:stretch>
+        </p:blipFill>
+        <p:spPr>
+          <a:xfrm>
+            <a:off x="4626864" y="2456627"/>
+            <a:ext cx="3915034" cy="2252532"/>
           </a:xfrm>
           <a:prstGeom prst="rect">
             <a:avLst/>

</xml_diff>